<commit_message>
Add instructor script (script.md) generator + enrich Day 1 slides
- build_script.py + script_notes.py → script.md (per-slide 화면 + 대본/진행)
- Day 1 (LLM) and Day 3 오후2 narration authored; rest marked [보강 예정]
- Day 1 concept slides: add example/analogy notes (less summary-like)

Co-Authored-By: Claude Opus 4.8 <noreply@anthropic.com>
</commit_message>
<xml_diff>
--- a/slides/day1.pptx
+++ b/slides/day1.pptx
@@ -7480,6 +7480,110 @@
           </a:p>
         </p:txBody>
       </p:sp>
+      <p:sp>
+        <p:nvSpPr>
+          <p:cNvPr id="18" name="Rounded Rectangle 17"/>
+          <p:cNvSpPr/>
+          <p:nvPr/>
+        </p:nvSpPr>
+        <p:spPr>
+          <a:xfrm>
+            <a:off x="502920" y="5532120"/>
+            <a:ext cx="11155680" cy="658368"/>
+          </a:xfrm>
+          <a:prstGeom prst="roundRect">
+            <a:avLst/>
+          </a:prstGeom>
+          <a:solidFill>
+            <a:srgbClr val="F1F5F9"/>
+          </a:solidFill>
+          <a:ln w="12700">
+            <a:solidFill>
+              <a:srgbClr val="E2E8F0"/>
+            </a:solidFill>
+          </a:ln>
+          <a:effectLst/>
+        </p:spPr>
+        <p:style>
+          <a:lnRef idx="1">
+            <a:schemeClr val="accent1"/>
+          </a:lnRef>
+          <a:fillRef idx="3">
+            <a:schemeClr val="accent1"/>
+          </a:fillRef>
+          <a:effectRef idx="2">
+            <a:schemeClr val="accent1"/>
+          </a:effectRef>
+          <a:fontRef idx="minor">
+            <a:schemeClr val="lt1"/>
+          </a:fontRef>
+        </p:style>
+        <p:txBody>
+          <a:bodyPr rtlCol="0" anchor="ctr"/>
+          <a:lstStyle/>
+          <a:p>
+            <a:pPr algn="ctr"/>
+          </a:p>
+        </p:txBody>
+      </p:sp>
+      <p:sp>
+        <p:nvSpPr>
+          <p:cNvPr id="19" name="TextBox 18"/>
+          <p:cNvSpPr txBox="1"/>
+          <p:nvPr/>
+        </p:nvSpPr>
+        <p:spPr>
+          <a:xfrm>
+            <a:off x="777240" y="5532120"/>
+            <a:ext cx="10607040" cy="658368"/>
+          </a:xfrm>
+          <a:prstGeom prst="rect">
+            <a:avLst/>
+          </a:prstGeom>
+          <a:noFill/>
+        </p:spPr>
+        <p:txBody>
+          <a:bodyPr wrap="square" anchor="ctr" lIns="0" rIns="0" tIns="0" bIns="0">
+            <a:spAutoFit/>
+          </a:bodyPr>
+          <a:lstStyle/>
+          <a:p>
+            <a:pPr algn="l">
+              <a:lnSpc>
+                <a:spcPct val="100000"/>
+              </a:lnSpc>
+              <a:spcBef>
+                <a:spcPts val="0"/>
+              </a:spcBef>
+              <a:spcAft>
+                <a:spcPts val="600"/>
+              </a:spcAft>
+            </a:pPr>
+            <a:r>
+              <a:rPr sz="1200" b="1">
+                <a:solidFill>
+                  <a:srgbClr val="6366F1"/>
+                </a:solidFill>
+                <a:latin typeface="NanumGothic"/>
+                <a:ea typeface="NanumGothic"/>
+                <a:cs typeface="NanumGothic"/>
+              </a:rPr>
+              <a:t>NOTE   </a:t>
+            </a:r>
+            <a:r>
+              <a:rPr sz="1300" b="0">
+                <a:solidFill>
+                  <a:srgbClr val="0F172A"/>
+                </a:solidFill>
+                <a:latin typeface="NanumGothic"/>
+                <a:ea typeface="NanumGothic"/>
+                <a:cs typeface="NanumGothic"/>
+              </a:rPr>
+              <a:t>비교: '코딩 도와줘' vs 'CSV 항목별 합계 코드 만들고 실행·확인해줘'</a:t>
+            </a:r>
+          </a:p>
+        </p:txBody>
+      </p:sp>
     </p:spTree>
   </p:cSld>
   <p:clrMapOvr>
@@ -9736,6 +9840,110 @@
           </a:p>
         </p:txBody>
       </p:sp>
+      <p:sp>
+        <p:nvSpPr>
+          <p:cNvPr id="18" name="Rounded Rectangle 17"/>
+          <p:cNvSpPr/>
+          <p:nvPr/>
+        </p:nvSpPr>
+        <p:spPr>
+          <a:xfrm>
+            <a:off x="502920" y="5532120"/>
+            <a:ext cx="11155680" cy="658368"/>
+          </a:xfrm>
+          <a:prstGeom prst="roundRect">
+            <a:avLst/>
+          </a:prstGeom>
+          <a:solidFill>
+            <a:srgbClr val="F1F5F9"/>
+          </a:solidFill>
+          <a:ln w="12700">
+            <a:solidFill>
+              <a:srgbClr val="E2E8F0"/>
+            </a:solidFill>
+          </a:ln>
+          <a:effectLst/>
+        </p:spPr>
+        <p:style>
+          <a:lnRef idx="1">
+            <a:schemeClr val="accent1"/>
+          </a:lnRef>
+          <a:fillRef idx="3">
+            <a:schemeClr val="accent1"/>
+          </a:fillRef>
+          <a:effectRef idx="2">
+            <a:schemeClr val="accent1"/>
+          </a:effectRef>
+          <a:fontRef idx="minor">
+            <a:schemeClr val="lt1"/>
+          </a:fontRef>
+        </p:style>
+        <p:txBody>
+          <a:bodyPr rtlCol="0" anchor="ctr"/>
+          <a:lstStyle/>
+          <a:p>
+            <a:pPr algn="ctr"/>
+          </a:p>
+        </p:txBody>
+      </p:sp>
+      <p:sp>
+        <p:nvSpPr>
+          <p:cNvPr id="19" name="TextBox 18"/>
+          <p:cNvSpPr txBox="1"/>
+          <p:nvPr/>
+        </p:nvSpPr>
+        <p:spPr>
+          <a:xfrm>
+            <a:off x="777240" y="5532120"/>
+            <a:ext cx="10607040" cy="658368"/>
+          </a:xfrm>
+          <a:prstGeom prst="rect">
+            <a:avLst/>
+          </a:prstGeom>
+          <a:noFill/>
+        </p:spPr>
+        <p:txBody>
+          <a:bodyPr wrap="square" anchor="ctr" lIns="0" rIns="0" tIns="0" bIns="0">
+            <a:spAutoFit/>
+          </a:bodyPr>
+          <a:lstStyle/>
+          <a:p>
+            <a:pPr algn="l">
+              <a:lnSpc>
+                <a:spcPct val="100000"/>
+              </a:lnSpc>
+              <a:spcBef>
+                <a:spcPts val="0"/>
+              </a:spcBef>
+              <a:spcAft>
+                <a:spcPts val="600"/>
+              </a:spcAft>
+            </a:pPr>
+            <a:r>
+              <a:rPr sz="1200" b="1">
+                <a:solidFill>
+                  <a:srgbClr val="6366F1"/>
+                </a:solidFill>
+                <a:latin typeface="NanumGothic"/>
+                <a:ea typeface="NanumGothic"/>
+                <a:cs typeface="NanumGothic"/>
+              </a:rPr>
+              <a:t>NOTE   </a:t>
+            </a:r>
+            <a:r>
+              <a:rPr sz="1300" b="0">
+                <a:solidFill>
+                  <a:srgbClr val="0F172A"/>
+                </a:solidFill>
+                <a:latin typeface="NanumGothic"/>
+                <a:ea typeface="NanumGothic"/>
+                <a:cs typeface="NanumGothic"/>
+              </a:rPr>
+              <a:t>긴 문서를 통째로 넣기보다, 검색으로 필요한 부분만 → RAG의 이유</a:t>
+            </a:r>
+          </a:p>
+        </p:txBody>
+      </p:sp>
     </p:spTree>
   </p:cSld>
   <p:clrMapOvr>
@@ -11564,6 +11772,110 @@
           </a:p>
         </p:txBody>
       </p:sp>
+      <p:sp>
+        <p:nvSpPr>
+          <p:cNvPr id="18" name="Rounded Rectangle 17"/>
+          <p:cNvSpPr/>
+          <p:nvPr/>
+        </p:nvSpPr>
+        <p:spPr>
+          <a:xfrm>
+            <a:off x="502920" y="5532120"/>
+            <a:ext cx="11155680" cy="658368"/>
+          </a:xfrm>
+          <a:prstGeom prst="roundRect">
+            <a:avLst/>
+          </a:prstGeom>
+          <a:solidFill>
+            <a:srgbClr val="F1F5F9"/>
+          </a:solidFill>
+          <a:ln w="12700">
+            <a:solidFill>
+              <a:srgbClr val="E2E8F0"/>
+            </a:solidFill>
+          </a:ln>
+          <a:effectLst/>
+        </p:spPr>
+        <p:style>
+          <a:lnRef idx="1">
+            <a:schemeClr val="accent1"/>
+          </a:lnRef>
+          <a:fillRef idx="3">
+            <a:schemeClr val="accent1"/>
+          </a:fillRef>
+          <a:effectRef idx="2">
+            <a:schemeClr val="accent1"/>
+          </a:effectRef>
+          <a:fontRef idx="minor">
+            <a:schemeClr val="lt1"/>
+          </a:fontRef>
+        </p:style>
+        <p:txBody>
+          <a:bodyPr rtlCol="0" anchor="ctr"/>
+          <a:lstStyle/>
+          <a:p>
+            <a:pPr algn="ctr"/>
+          </a:p>
+        </p:txBody>
+      </p:sp>
+      <p:sp>
+        <p:nvSpPr>
+          <p:cNvPr id="19" name="TextBox 18"/>
+          <p:cNvSpPr txBox="1"/>
+          <p:nvPr/>
+        </p:nvSpPr>
+        <p:spPr>
+          <a:xfrm>
+            <a:off x="777240" y="5532120"/>
+            <a:ext cx="10607040" cy="658368"/>
+          </a:xfrm>
+          <a:prstGeom prst="rect">
+            <a:avLst/>
+          </a:prstGeom>
+          <a:noFill/>
+        </p:spPr>
+        <p:txBody>
+          <a:bodyPr wrap="square" anchor="ctr" lIns="0" rIns="0" tIns="0" bIns="0">
+            <a:spAutoFit/>
+          </a:bodyPr>
+          <a:lstStyle/>
+          <a:p>
+            <a:pPr algn="l">
+              <a:lnSpc>
+                <a:spcPct val="100000"/>
+              </a:lnSpc>
+              <a:spcBef>
+                <a:spcPts val="0"/>
+              </a:spcBef>
+              <a:spcAft>
+                <a:spcPts val="600"/>
+              </a:spcAft>
+            </a:pPr>
+            <a:r>
+              <a:rPr sz="1200" b="1">
+                <a:solidFill>
+                  <a:srgbClr val="6366F1"/>
+                </a:solidFill>
+                <a:latin typeface="NanumGothic"/>
+                <a:ea typeface="NanumGothic"/>
+                <a:cs typeface="NanumGothic"/>
+              </a:rPr>
+              <a:t>NOTE   </a:t>
+            </a:r>
+            <a:r>
+              <a:rPr sz="1300" b="0">
+                <a:solidFill>
+                  <a:srgbClr val="0F172A"/>
+                </a:solidFill>
+                <a:latin typeface="NanumGothic"/>
+                <a:ea typeface="NanumGothic"/>
+                <a:cs typeface="NanumGothic"/>
+              </a:rPr>
+              <a:t>특히 출처·인용·수치를 지어낼 때 위험 — 반드시 교차확인</a:t>
+            </a:r>
+          </a:p>
+        </p:txBody>
+      </p:sp>
     </p:spTree>
   </p:cSld>
   <p:clrMapOvr>
@@ -19355,6 +19667,110 @@
           </a:p>
         </p:txBody>
       </p:sp>
+      <p:sp>
+        <p:nvSpPr>
+          <p:cNvPr id="18" name="Rounded Rectangle 17"/>
+          <p:cNvSpPr/>
+          <p:nvPr/>
+        </p:nvSpPr>
+        <p:spPr>
+          <a:xfrm>
+            <a:off x="502920" y="5532120"/>
+            <a:ext cx="11155680" cy="658368"/>
+          </a:xfrm>
+          <a:prstGeom prst="roundRect">
+            <a:avLst/>
+          </a:prstGeom>
+          <a:solidFill>
+            <a:srgbClr val="F1F5F9"/>
+          </a:solidFill>
+          <a:ln w="12700">
+            <a:solidFill>
+              <a:srgbClr val="E2E8F0"/>
+            </a:solidFill>
+          </a:ln>
+          <a:effectLst/>
+        </p:spPr>
+        <p:style>
+          <a:lnRef idx="1">
+            <a:schemeClr val="accent1"/>
+          </a:lnRef>
+          <a:fillRef idx="3">
+            <a:schemeClr val="accent1"/>
+          </a:fillRef>
+          <a:effectRef idx="2">
+            <a:schemeClr val="accent1"/>
+          </a:effectRef>
+          <a:fontRef idx="minor">
+            <a:schemeClr val="lt1"/>
+          </a:fontRef>
+        </p:style>
+        <p:txBody>
+          <a:bodyPr rtlCol="0" anchor="ctr"/>
+          <a:lstStyle/>
+          <a:p>
+            <a:pPr algn="ctr"/>
+          </a:p>
+        </p:txBody>
+      </p:sp>
+      <p:sp>
+        <p:nvSpPr>
+          <p:cNvPr id="19" name="TextBox 18"/>
+          <p:cNvSpPr txBox="1"/>
+          <p:nvPr/>
+        </p:nvSpPr>
+        <p:spPr>
+          <a:xfrm>
+            <a:off x="777240" y="5532120"/>
+            <a:ext cx="10607040" cy="658368"/>
+          </a:xfrm>
+          <a:prstGeom prst="rect">
+            <a:avLst/>
+          </a:prstGeom>
+          <a:noFill/>
+        </p:spPr>
+        <p:txBody>
+          <a:bodyPr wrap="square" anchor="ctr" lIns="0" rIns="0" tIns="0" bIns="0">
+            <a:spAutoFit/>
+          </a:bodyPr>
+          <a:lstStyle/>
+          <a:p>
+            <a:pPr algn="l">
+              <a:lnSpc>
+                <a:spcPct val="100000"/>
+              </a:lnSpc>
+              <a:spcBef>
+                <a:spcPts val="0"/>
+              </a:spcBef>
+              <a:spcAft>
+                <a:spcPts val="600"/>
+              </a:spcAft>
+            </a:pPr>
+            <a:r>
+              <a:rPr sz="1200" b="1">
+                <a:solidFill>
+                  <a:srgbClr val="6366F1"/>
+                </a:solidFill>
+                <a:latin typeface="NanumGothic"/>
+                <a:ea typeface="NanumGothic"/>
+                <a:cs typeface="NanumGothic"/>
+              </a:rPr>
+              <a:t>NOTE   </a:t>
+            </a:r>
+            <a:r>
+              <a:rPr sz="1300" b="0">
+                <a:solidFill>
+                  <a:srgbClr val="0F172A"/>
+                </a:solidFill>
+                <a:latin typeface="NanumGothic"/>
+                <a:ea typeface="NanumGothic"/>
+                <a:cs typeface="NanumGothic"/>
+              </a:rPr>
+              <a:t>예: '커피를 마시면 잠이 ___' 다음에 올 토큰을 확률로 고른다</a:t>
+            </a:r>
+          </a:p>
+        </p:txBody>
+      </p:sp>
     </p:spTree>
   </p:cSld>
   <p:clrMapOvr>
@@ -21614,6 +22030,110 @@
           </a:p>
         </p:txBody>
       </p:sp>
+      <p:sp>
+        <p:nvSpPr>
+          <p:cNvPr id="18" name="Rounded Rectangle 17"/>
+          <p:cNvSpPr/>
+          <p:nvPr/>
+        </p:nvSpPr>
+        <p:spPr>
+          <a:xfrm>
+            <a:off x="502920" y="5532120"/>
+            <a:ext cx="11155680" cy="658368"/>
+          </a:xfrm>
+          <a:prstGeom prst="roundRect">
+            <a:avLst/>
+          </a:prstGeom>
+          <a:solidFill>
+            <a:srgbClr val="F1F5F9"/>
+          </a:solidFill>
+          <a:ln w="12700">
+            <a:solidFill>
+              <a:srgbClr val="E2E8F0"/>
+            </a:solidFill>
+          </a:ln>
+          <a:effectLst/>
+        </p:spPr>
+        <p:style>
+          <a:lnRef idx="1">
+            <a:schemeClr val="accent1"/>
+          </a:lnRef>
+          <a:fillRef idx="3">
+            <a:schemeClr val="accent1"/>
+          </a:fillRef>
+          <a:effectRef idx="2">
+            <a:schemeClr val="accent1"/>
+          </a:effectRef>
+          <a:fontRef idx="minor">
+            <a:schemeClr val="lt1"/>
+          </a:fontRef>
+        </p:style>
+        <p:txBody>
+          <a:bodyPr rtlCol="0" anchor="ctr"/>
+          <a:lstStyle/>
+          <a:p>
+            <a:pPr algn="ctr"/>
+          </a:p>
+        </p:txBody>
+      </p:sp>
+      <p:sp>
+        <p:nvSpPr>
+          <p:cNvPr id="19" name="TextBox 18"/>
+          <p:cNvSpPr txBox="1"/>
+          <p:nvPr/>
+        </p:nvSpPr>
+        <p:spPr>
+          <a:xfrm>
+            <a:off x="777240" y="5532120"/>
+            <a:ext cx="10607040" cy="658368"/>
+          </a:xfrm>
+          <a:prstGeom prst="rect">
+            <a:avLst/>
+          </a:prstGeom>
+          <a:noFill/>
+        </p:spPr>
+        <p:txBody>
+          <a:bodyPr wrap="square" anchor="ctr" lIns="0" rIns="0" tIns="0" bIns="0">
+            <a:spAutoFit/>
+          </a:bodyPr>
+          <a:lstStyle/>
+          <a:p>
+            <a:pPr algn="l">
+              <a:lnSpc>
+                <a:spcPct val="100000"/>
+              </a:lnSpc>
+              <a:spcBef>
+                <a:spcPts val="0"/>
+              </a:spcBef>
+              <a:spcAft>
+                <a:spcPts val="600"/>
+              </a:spcAft>
+            </a:pPr>
+            <a:r>
+              <a:rPr sz="1200" b="1">
+                <a:solidFill>
+                  <a:srgbClr val="6366F1"/>
+                </a:solidFill>
+                <a:latin typeface="NanumGothic"/>
+                <a:ea typeface="NanumGothic"/>
+                <a:cs typeface="NanumGothic"/>
+              </a:rPr>
+              <a:t>NOTE   </a:t>
+            </a:r>
+            <a:r>
+              <a:rPr sz="1300" b="0">
+                <a:solidFill>
+                  <a:srgbClr val="0F172A"/>
+                </a:solidFill>
+                <a:latin typeface="NanumGothic"/>
+                <a:ea typeface="NanumGothic"/>
+                <a:cs typeface="NanumGothic"/>
+              </a:rPr>
+              <a:t>비유: 거대한 빈칸 채우기를 수십억 번 — 그 과정에서 지식이 '딸려' 학습된다</a:t>
+            </a:r>
+          </a:p>
+        </p:txBody>
+      </p:sp>
     </p:spTree>
   </p:cSld>
   <p:clrMapOvr>
@@ -22362,6 +22882,110 @@
                 <a:cs typeface="NanumGothic"/>
               </a:rPr>
               <a:t>사람이 선호하는 답을 강화 — 도움되고 해롭지 않게</a:t>
+            </a:r>
+          </a:p>
+        </p:txBody>
+      </p:sp>
+      <p:sp>
+        <p:nvSpPr>
+          <p:cNvPr id="18" name="Rounded Rectangle 17"/>
+          <p:cNvSpPr/>
+          <p:nvPr/>
+        </p:nvSpPr>
+        <p:spPr>
+          <a:xfrm>
+            <a:off x="502920" y="5532120"/>
+            <a:ext cx="11155680" cy="658368"/>
+          </a:xfrm>
+          <a:prstGeom prst="roundRect">
+            <a:avLst/>
+          </a:prstGeom>
+          <a:solidFill>
+            <a:srgbClr val="F1F5F9"/>
+          </a:solidFill>
+          <a:ln w="12700">
+            <a:solidFill>
+              <a:srgbClr val="E2E8F0"/>
+            </a:solidFill>
+          </a:ln>
+          <a:effectLst/>
+        </p:spPr>
+        <p:style>
+          <a:lnRef idx="1">
+            <a:schemeClr val="accent1"/>
+          </a:lnRef>
+          <a:fillRef idx="3">
+            <a:schemeClr val="accent1"/>
+          </a:fillRef>
+          <a:effectRef idx="2">
+            <a:schemeClr val="accent1"/>
+          </a:effectRef>
+          <a:fontRef idx="minor">
+            <a:schemeClr val="lt1"/>
+          </a:fontRef>
+        </p:style>
+        <p:txBody>
+          <a:bodyPr rtlCol="0" anchor="ctr"/>
+          <a:lstStyle/>
+          <a:p>
+            <a:pPr algn="ctr"/>
+          </a:p>
+        </p:txBody>
+      </p:sp>
+      <p:sp>
+        <p:nvSpPr>
+          <p:cNvPr id="19" name="TextBox 18"/>
+          <p:cNvSpPr txBox="1"/>
+          <p:nvPr/>
+        </p:nvSpPr>
+        <p:spPr>
+          <a:xfrm>
+            <a:off x="777240" y="5532120"/>
+            <a:ext cx="10607040" cy="658368"/>
+          </a:xfrm>
+          <a:prstGeom prst="rect">
+            <a:avLst/>
+          </a:prstGeom>
+          <a:noFill/>
+        </p:spPr>
+        <p:txBody>
+          <a:bodyPr wrap="square" anchor="ctr" lIns="0" rIns="0" tIns="0" bIns="0">
+            <a:spAutoFit/>
+          </a:bodyPr>
+          <a:lstStyle/>
+          <a:p>
+            <a:pPr algn="l">
+              <a:lnSpc>
+                <a:spcPct val="100000"/>
+              </a:lnSpc>
+              <a:spcBef>
+                <a:spcPts val="0"/>
+              </a:spcBef>
+              <a:spcAft>
+                <a:spcPts val="600"/>
+              </a:spcAft>
+            </a:pPr>
+            <a:r>
+              <a:rPr sz="1200" b="1">
+                <a:solidFill>
+                  <a:srgbClr val="6366F1"/>
+                </a:solidFill>
+                <a:latin typeface="NanumGothic"/>
+                <a:ea typeface="NanumGothic"/>
+                <a:cs typeface="NanumGothic"/>
+              </a:rPr>
+              <a:t>NOTE   </a:t>
+            </a:r>
+            <a:r>
+              <a:rPr sz="1300" b="0">
+                <a:solidFill>
+                  <a:srgbClr val="0F172A"/>
+                </a:solidFill>
+                <a:latin typeface="NanumGothic"/>
+                <a:ea typeface="NanumGothic"/>
+                <a:cs typeface="NanumGothic"/>
+              </a:rPr>
+              <a:t>사전학습=박학다식 / 정렬=지시 잘 따르는 조수로 길들이기</a:t>
             </a:r>
           </a:p>
         </p:txBody>

</xml_diff>

<commit_message>
Embed real-world cases into Day 1 & 2 slides (self-contained: cases on slide)
Day 1: 환각(Mata v. Avianca·Air Canada), 정렬(InstructGPT), 추론(R1·o3), 임베딩(Etsy·Spotify),
RAG(OpenEvidence), few-shot(GPT-3), 컨텍스트(Claude 1M), 모델선택(가격 티어)
Day 2: 에이전트(Claude Code·Computer use), 도구(ChatGPT Search), 자율성(Copilot→Devin),
바이브코딩(Karpathy·Fly.Pieter), 실패(Replit DB삭제), 리서치(Deep Research) + NEW '과학·신약' slide (AlphaFold·Insilico·co-scientist)
- timetable Day2 slot1 row updated to match

Co-Authored-By: Claude Opus 4.8 <noreply@anthropic.com>
</commit_message>
<xml_diff>
--- a/slides/day1.pptx
+++ b/slides/day1.pptx
@@ -4365,6 +4365,110 @@
           </a:p>
         </p:txBody>
       </p:sp>
+      <p:sp>
+        <p:nvSpPr>
+          <p:cNvPr id="18" name="Rounded Rectangle 17"/>
+          <p:cNvSpPr/>
+          <p:nvPr/>
+        </p:nvSpPr>
+        <p:spPr>
+          <a:xfrm>
+            <a:off x="502920" y="5532120"/>
+            <a:ext cx="11155680" cy="658368"/>
+          </a:xfrm>
+          <a:prstGeom prst="roundRect">
+            <a:avLst/>
+          </a:prstGeom>
+          <a:solidFill>
+            <a:srgbClr val="F1F5F9"/>
+          </a:solidFill>
+          <a:ln w="12700">
+            <a:solidFill>
+              <a:srgbClr val="E2E8F0"/>
+            </a:solidFill>
+          </a:ln>
+          <a:effectLst/>
+        </p:spPr>
+        <p:style>
+          <a:lnRef idx="1">
+            <a:schemeClr val="accent1"/>
+          </a:lnRef>
+          <a:fillRef idx="3">
+            <a:schemeClr val="accent1"/>
+          </a:fillRef>
+          <a:effectRef idx="2">
+            <a:schemeClr val="accent1"/>
+          </a:effectRef>
+          <a:fontRef idx="minor">
+            <a:schemeClr val="lt1"/>
+          </a:fontRef>
+        </p:style>
+        <p:txBody>
+          <a:bodyPr rtlCol="0" anchor="ctr"/>
+          <a:lstStyle/>
+          <a:p>
+            <a:pPr algn="ctr"/>
+          </a:p>
+        </p:txBody>
+      </p:sp>
+      <p:sp>
+        <p:nvSpPr>
+          <p:cNvPr id="19" name="TextBox 18"/>
+          <p:cNvSpPr txBox="1"/>
+          <p:nvPr/>
+        </p:nvSpPr>
+        <p:spPr>
+          <a:xfrm>
+            <a:off x="777240" y="5532120"/>
+            <a:ext cx="10607040" cy="658368"/>
+          </a:xfrm>
+          <a:prstGeom prst="rect">
+            <a:avLst/>
+          </a:prstGeom>
+          <a:noFill/>
+        </p:spPr>
+        <p:txBody>
+          <a:bodyPr wrap="square" anchor="ctr" lIns="0" rIns="0" tIns="0" bIns="0">
+            <a:spAutoFit/>
+          </a:bodyPr>
+          <a:lstStyle/>
+          <a:p>
+            <a:pPr algn="l">
+              <a:lnSpc>
+                <a:spcPct val="100000"/>
+              </a:lnSpc>
+              <a:spcBef>
+                <a:spcPts val="0"/>
+              </a:spcBef>
+              <a:spcAft>
+                <a:spcPts val="600"/>
+              </a:spcAft>
+            </a:pPr>
+            <a:r>
+              <a:rPr sz="1200" b="1">
+                <a:solidFill>
+                  <a:srgbClr val="6366F1"/>
+                </a:solidFill>
+                <a:latin typeface="NanumGothic"/>
+                <a:ea typeface="NanumGothic"/>
+                <a:cs typeface="NanumGothic"/>
+              </a:rPr>
+              <a:t>NOTE   </a:t>
+            </a:r>
+            <a:r>
+              <a:rPr sz="1300" b="0">
+                <a:solidFill>
+                  <a:srgbClr val="0F172A"/>
+                </a:solidFill>
+                <a:latin typeface="NanumGothic"/>
+                <a:ea typeface="NanumGothic"/>
+                <a:cs typeface="NanumGothic"/>
+              </a:rPr>
+              <a:t>사례: DeepSeek-R1(2025·오픈)·OpenAI o1→o3 — AIME 78%→96.7% (벤치마크는 빠르게 바뀜)</a:t>
+            </a:r>
+          </a:p>
+        </p:txBody>
+      </p:sp>
     </p:spTree>
   </p:cSld>
   <p:clrMapOvr>
@@ -5216,7 +5320,7 @@
                 <a:ea typeface="NanumGothic"/>
                 <a:cs typeface="NanumGothic"/>
               </a:rPr>
-              <a:t>키워드가 아니라 '의미'로 찾는다</a:t>
+              <a:t>키워드가 아니라 '의미'로 찾는다 · 사례: Etsy·Spotify 검색/추천이 임베딩 기반</a:t>
             </a:r>
           </a:p>
         </p:txBody>
@@ -6723,7 +6827,7 @@
                 <a:ea typeface="NanumGothic"/>
                 <a:cs typeface="NanumGothic"/>
               </a:rPr>
-              <a:t>외부 지식을 붙여 환각↓·최신성↑ — 리서치 에이전트의 핵심 패턴</a:t>
+              <a:t>사례: OpenEvidence — 동료심사 문헌(NEJM·JAMA) 기반 의사용 Q&amp;A (약학 RAG 예)</a:t>
             </a:r>
           </a:p>
         </p:txBody>
@@ -8336,6 +8440,110 @@
           </a:p>
         </p:txBody>
       </p:sp>
+      <p:sp>
+        <p:nvSpPr>
+          <p:cNvPr id="18" name="Rounded Rectangle 17"/>
+          <p:cNvSpPr/>
+          <p:nvPr/>
+        </p:nvSpPr>
+        <p:spPr>
+          <a:xfrm>
+            <a:off x="502920" y="5532120"/>
+            <a:ext cx="11155680" cy="658368"/>
+          </a:xfrm>
+          <a:prstGeom prst="roundRect">
+            <a:avLst/>
+          </a:prstGeom>
+          <a:solidFill>
+            <a:srgbClr val="F1F5F9"/>
+          </a:solidFill>
+          <a:ln w="12700">
+            <a:solidFill>
+              <a:srgbClr val="E2E8F0"/>
+            </a:solidFill>
+          </a:ln>
+          <a:effectLst/>
+        </p:spPr>
+        <p:style>
+          <a:lnRef idx="1">
+            <a:schemeClr val="accent1"/>
+          </a:lnRef>
+          <a:fillRef idx="3">
+            <a:schemeClr val="accent1"/>
+          </a:fillRef>
+          <a:effectRef idx="2">
+            <a:schemeClr val="accent1"/>
+          </a:effectRef>
+          <a:fontRef idx="minor">
+            <a:schemeClr val="lt1"/>
+          </a:fontRef>
+        </p:style>
+        <p:txBody>
+          <a:bodyPr rtlCol="0" anchor="ctr"/>
+          <a:lstStyle/>
+          <a:p>
+            <a:pPr algn="ctr"/>
+          </a:p>
+        </p:txBody>
+      </p:sp>
+      <p:sp>
+        <p:nvSpPr>
+          <p:cNvPr id="19" name="TextBox 18"/>
+          <p:cNvSpPr txBox="1"/>
+          <p:nvPr/>
+        </p:nvSpPr>
+        <p:spPr>
+          <a:xfrm>
+            <a:off x="777240" y="5532120"/>
+            <a:ext cx="10607040" cy="658368"/>
+          </a:xfrm>
+          <a:prstGeom prst="rect">
+            <a:avLst/>
+          </a:prstGeom>
+          <a:noFill/>
+        </p:spPr>
+        <p:txBody>
+          <a:bodyPr wrap="square" anchor="ctr" lIns="0" rIns="0" tIns="0" bIns="0">
+            <a:spAutoFit/>
+          </a:bodyPr>
+          <a:lstStyle/>
+          <a:p>
+            <a:pPr algn="l">
+              <a:lnSpc>
+                <a:spcPct val="100000"/>
+              </a:lnSpc>
+              <a:spcBef>
+                <a:spcPts val="0"/>
+              </a:spcBef>
+              <a:spcAft>
+                <a:spcPts val="600"/>
+              </a:spcAft>
+            </a:pPr>
+            <a:r>
+              <a:rPr sz="1200" b="1">
+                <a:solidFill>
+                  <a:srgbClr val="6366F1"/>
+                </a:solidFill>
+                <a:latin typeface="NanumGothic"/>
+                <a:ea typeface="NanumGothic"/>
+                <a:cs typeface="NanumGothic"/>
+              </a:rPr>
+              <a:t>NOTE   </a:t>
+            </a:r>
+            <a:r>
+              <a:rPr sz="1300" b="0">
+                <a:solidFill>
+                  <a:srgbClr val="0F172A"/>
+                </a:solidFill>
+                <a:latin typeface="NanumGothic"/>
+                <a:ea typeface="NanumGothic"/>
+                <a:cs typeface="NanumGothic"/>
+              </a:rPr>
+              <a:t>사례: GPT-3(2020) — 예시 몇 개(few-shot)만으로 번역·Q&amp;A 수행</a:t>
+            </a:r>
+          </a:p>
+        </p:txBody>
+      </p:sp>
     </p:spTree>
   </p:cSld>
   <p:clrMapOvr>
@@ -9939,7 +10147,7 @@
                 <a:ea typeface="NanumGothic"/>
                 <a:cs typeface="NanumGothic"/>
               </a:rPr>
-              <a:t>긴 문서를 통째로 넣기보다, 검색으로 필요한 부분만 → RAG의 이유</a:t>
+              <a:t>현재 Claude 최대 1M 토큰(≈책 여러 권) — 긴 문서·코드 통째 분석 (단 lost in the middle 주의)</a:t>
             </a:r>
           </a:p>
         </p:txBody>
@@ -11871,7 +12079,7 @@
                 <a:ea typeface="NanumGothic"/>
                 <a:cs typeface="NanumGothic"/>
               </a:rPr>
-              <a:t>특히 출처·인용·수치를 지어낼 때 위험 — 반드시 교차확인</a:t>
+              <a:t>실제 사례: 변호사가 ChatGPT 가짜 판례 인용→벌금(Mata v. Avianca, 2023) · 에어캐나다 챗봇이 없는 환불정책 지어내 배상(2024)</a:t>
             </a:r>
           </a:p>
         </p:txBody>
@@ -12628,6 +12836,110 @@
           </a:p>
         </p:txBody>
       </p:sp>
+      <p:sp>
+        <p:nvSpPr>
+          <p:cNvPr id="18" name="Rounded Rectangle 17"/>
+          <p:cNvSpPr/>
+          <p:nvPr/>
+        </p:nvSpPr>
+        <p:spPr>
+          <a:xfrm>
+            <a:off x="502920" y="5532120"/>
+            <a:ext cx="11155680" cy="658368"/>
+          </a:xfrm>
+          <a:prstGeom prst="roundRect">
+            <a:avLst/>
+          </a:prstGeom>
+          <a:solidFill>
+            <a:srgbClr val="F1F5F9"/>
+          </a:solidFill>
+          <a:ln w="12700">
+            <a:solidFill>
+              <a:srgbClr val="E2E8F0"/>
+            </a:solidFill>
+          </a:ln>
+          <a:effectLst/>
+        </p:spPr>
+        <p:style>
+          <a:lnRef idx="1">
+            <a:schemeClr val="accent1"/>
+          </a:lnRef>
+          <a:fillRef idx="3">
+            <a:schemeClr val="accent1"/>
+          </a:fillRef>
+          <a:effectRef idx="2">
+            <a:schemeClr val="accent1"/>
+          </a:effectRef>
+          <a:fontRef idx="minor">
+            <a:schemeClr val="lt1"/>
+          </a:fontRef>
+        </p:style>
+        <p:txBody>
+          <a:bodyPr rtlCol="0" anchor="ctr"/>
+          <a:lstStyle/>
+          <a:p>
+            <a:pPr algn="ctr"/>
+          </a:p>
+        </p:txBody>
+      </p:sp>
+      <p:sp>
+        <p:nvSpPr>
+          <p:cNvPr id="19" name="TextBox 18"/>
+          <p:cNvSpPr txBox="1"/>
+          <p:nvPr/>
+        </p:nvSpPr>
+        <p:spPr>
+          <a:xfrm>
+            <a:off x="777240" y="5532120"/>
+            <a:ext cx="10607040" cy="658368"/>
+          </a:xfrm>
+          <a:prstGeom prst="rect">
+            <a:avLst/>
+          </a:prstGeom>
+          <a:noFill/>
+        </p:spPr>
+        <p:txBody>
+          <a:bodyPr wrap="square" anchor="ctr" lIns="0" rIns="0" tIns="0" bIns="0">
+            <a:spAutoFit/>
+          </a:bodyPr>
+          <a:lstStyle/>
+          <a:p>
+            <a:pPr algn="l">
+              <a:lnSpc>
+                <a:spcPct val="100000"/>
+              </a:lnSpc>
+              <a:spcBef>
+                <a:spcPts val="0"/>
+              </a:spcBef>
+              <a:spcAft>
+                <a:spcPts val="600"/>
+              </a:spcAft>
+            </a:pPr>
+            <a:r>
+              <a:rPr sz="1200" b="1">
+                <a:solidFill>
+                  <a:srgbClr val="6366F1"/>
+                </a:solidFill>
+                <a:latin typeface="NanumGothic"/>
+                <a:ea typeface="NanumGothic"/>
+                <a:cs typeface="NanumGothic"/>
+              </a:rPr>
+              <a:t>NOTE   </a:t>
+            </a:r>
+            <a:r>
+              <a:rPr sz="1300" b="0">
+                <a:solidFill>
+                  <a:srgbClr val="0F172A"/>
+                </a:solidFill>
+                <a:latin typeface="NanumGothic"/>
+                <a:ea typeface="NanumGothic"/>
+                <a:cs typeface="NanumGothic"/>
+              </a:rPr>
+              <a:t>참고 가격(~2026.6, 1M토큰 입력/출력): Opus $5/$25 · Sonnet $3/$15 · Haiku $1/$5 (변동)</a:t>
+            </a:r>
+          </a:p>
+        </p:txBody>
+      </p:sp>
     </p:spTree>
   </p:cSld>
   <p:clrMapOvr>
@@ -22985,7 +23297,7 @@
                 <a:ea typeface="NanumGothic"/>
                 <a:cs typeface="NanumGothic"/>
               </a:rPr>
-              <a:t>사전학습=박학다식 / 정렬=지시 잘 따르는 조수로 길들이기</a:t>
+              <a:t>사례: InstructGPT(2022) — 정렬한 1.3B 답을 175B GPT-3보다 사람이 선호(~71%)</a:t>
             </a:r>
           </a:p>
         </p:txBody>

</xml_diff>

<commit_message>
Finalize footer text: '신약 개발을 위한 AI Agent 특강'
Co-Authored-By: Claude Opus 4.8 <noreply@anthropic.com>
</commit_message>
<xml_diff>
--- a/slides/day1.pptx
+++ b/slides/day1.pptx
@@ -3978,7 +3978,7 @@
                 <a:ea typeface="NanumGothic"/>
                 <a:cs typeface="NanumGothic"/>
               </a:rPr>
-              <a:t>AI 에이전트와 응용  ·  원광대학교 5일 교육</a:t>
+              <a:t>신약 개발을 위한 AI Agent 특강</a:t>
             </a:r>
           </a:p>
         </p:txBody>
@@ -4845,7 +4845,7 @@
                 <a:ea typeface="NanumGothic"/>
                 <a:cs typeface="NanumGothic"/>
               </a:rPr>
-              <a:t>AI 에이전트와 응용  ·  원광대학교 5일 교육</a:t>
+              <a:t>신약 개발을 위한 AI Agent 특강</a:t>
             </a:r>
           </a:p>
         </p:txBody>
@@ -5712,7 +5712,7 @@
                 <a:ea typeface="NanumGothic"/>
                 <a:cs typeface="NanumGothic"/>
               </a:rPr>
-              <a:t>AI 에이전트와 응용  ·  원광대학교 5일 교육</a:t>
+              <a:t>신약 개발을 위한 AI Agent 특강</a:t>
             </a:r>
           </a:p>
         </p:txBody>
@@ -6717,7 +6717,7 @@
                 <a:ea typeface="NanumGothic"/>
                 <a:cs typeface="NanumGothic"/>
               </a:rPr>
-              <a:t>AI 에이전트와 응용  ·  원광대학교 5일 교육</a:t>
+              <a:t>신약 개발을 위한 AI Agent 특강</a:t>
             </a:r>
           </a:p>
         </p:txBody>
@@ -8235,7 +8235,7 @@
                 <a:ea typeface="NanumGothic"/>
                 <a:cs typeface="NanumGothic"/>
               </a:rPr>
-              <a:t>AI 에이전트와 응용  ·  원광대학교 5일 교육</a:t>
+              <a:t>신약 개발을 위한 AI Agent 특강</a:t>
             </a:r>
           </a:p>
         </p:txBody>
@@ -9240,7 +9240,7 @@
                 <a:ea typeface="NanumGothic"/>
                 <a:cs typeface="NanumGothic"/>
               </a:rPr>
-              <a:t>AI 에이전트와 응용  ·  원광대학교 5일 교육</a:t>
+              <a:t>신약 개발을 위한 AI Agent 특강</a:t>
             </a:r>
           </a:p>
         </p:txBody>
@@ -10107,7 +10107,7 @@
                 <a:ea typeface="NanumGothic"/>
                 <a:cs typeface="NanumGothic"/>
               </a:rPr>
-              <a:t>AI 에이전트와 응용  ·  원광대학교 5일 교육</a:t>
+              <a:t>신약 개발을 위한 AI Agent 특강</a:t>
             </a:r>
           </a:p>
         </p:txBody>
@@ -10974,7 +10974,7 @@
                 <a:ea typeface="NanumGothic"/>
                 <a:cs typeface="NanumGothic"/>
               </a:rPr>
-              <a:t>AI 에이전트와 응용  ·  원광대학교 5일 교육</a:t>
+              <a:t>신약 개발을 위한 AI Agent 특강</a:t>
             </a:r>
           </a:p>
         </p:txBody>
@@ -11841,7 +11841,7 @@
                 <a:ea typeface="NanumGothic"/>
                 <a:cs typeface="NanumGothic"/>
               </a:rPr>
-              <a:t>AI 에이전트와 응용  ·  원광대학교 5일 교육</a:t>
+              <a:t>신약 개발을 위한 AI Agent 특강</a:t>
             </a:r>
           </a:p>
         </p:txBody>
@@ -12846,7 +12846,7 @@
                 <a:ea typeface="NanumGothic"/>
                 <a:cs typeface="NanumGothic"/>
               </a:rPr>
-              <a:t>AI 에이전트와 응용  ·  원광대학교 5일 교육</a:t>
+              <a:t>신약 개발을 위한 AI Agent 특강</a:t>
             </a:r>
           </a:p>
         </p:txBody>
@@ -13851,7 +13851,7 @@
                 <a:ea typeface="NanumGothic"/>
                 <a:cs typeface="NanumGothic"/>
               </a:rPr>
-              <a:t>AI 에이전트와 응용  ·  원광대학교 5일 교육</a:t>
+              <a:t>신약 개발을 위한 AI Agent 특강</a:t>
             </a:r>
           </a:p>
         </p:txBody>
@@ -15123,7 +15123,7 @@
                 <a:ea typeface="NanumGothic"/>
                 <a:cs typeface="NanumGothic"/>
               </a:rPr>
-              <a:t>AI 에이전트와 응용  ·  원광대학교 5일 교육</a:t>
+              <a:t>신약 개발을 위한 AI Agent 특강</a:t>
             </a:r>
           </a:p>
         </p:txBody>
@@ -16363,7 +16363,7 @@
                 <a:ea typeface="NanumGothic"/>
                 <a:cs typeface="NanumGothic"/>
               </a:rPr>
-              <a:t>AI 에이전트와 응용  ·  원광대학교 5일 교육</a:t>
+              <a:t>신약 개발을 위한 AI Agent 특강</a:t>
             </a:r>
           </a:p>
         </p:txBody>
@@ -17126,7 +17126,7 @@
                 <a:ea typeface="NanumGothic"/>
                 <a:cs typeface="NanumGothic"/>
               </a:rPr>
-              <a:t>AI 에이전트와 응용  ·  원광대학교 5일 교육</a:t>
+              <a:t>신약 개발을 위한 AI Agent 특강</a:t>
             </a:r>
           </a:p>
         </p:txBody>
@@ -17889,7 +17889,7 @@
                 <a:ea typeface="NanumGothic"/>
                 <a:cs typeface="NanumGothic"/>
               </a:rPr>
-              <a:t>AI 에이전트와 응용  ·  원광대학교 5일 교육</a:t>
+              <a:t>신약 개발을 위한 AI Agent 특강</a:t>
             </a:r>
           </a:p>
         </p:txBody>
@@ -18652,7 +18652,7 @@
                 <a:ea typeface="NanumGothic"/>
                 <a:cs typeface="NanumGothic"/>
               </a:rPr>
-              <a:t>AI 에이전트와 응용  ·  원광대학교 5일 교육</a:t>
+              <a:t>신약 개발을 위한 AI Agent 특강</a:t>
             </a:r>
           </a:p>
         </p:txBody>
@@ -19657,7 +19657,7 @@
                 <a:ea typeface="NanumGothic"/>
                 <a:cs typeface="NanumGothic"/>
               </a:rPr>
-              <a:t>AI 에이전트와 응용  ·  원광대학교 5일 교육</a:t>
+              <a:t>신약 개발을 위한 AI Agent 특강</a:t>
             </a:r>
           </a:p>
         </p:txBody>
@@ -20662,7 +20662,7 @@
                 <a:ea typeface="NanumGothic"/>
                 <a:cs typeface="NanumGothic"/>
               </a:rPr>
-              <a:t>AI 에이전트와 응용  ·  원광대학교 5일 교육</a:t>
+              <a:t>신약 개발을 위한 AI Agent 특강</a:t>
             </a:r>
           </a:p>
         </p:txBody>
@@ -22180,7 +22180,7 @@
                 <a:ea typeface="NanumGothic"/>
                 <a:cs typeface="NanumGothic"/>
               </a:rPr>
-              <a:t>AI 에이전트와 응용  ·  원광대학교 5일 교육</a:t>
+              <a:t>신약 개발을 위한 AI Agent 특강</a:t>
             </a:r>
           </a:p>
         </p:txBody>
@@ -22943,7 +22943,7 @@
                 <a:ea typeface="NanumGothic"/>
                 <a:cs typeface="NanumGothic"/>
               </a:rPr>
-              <a:t>AI 에이전트와 응용  ·  원광대학교 5일 교육</a:t>
+              <a:t>신약 개발을 위한 AI Agent 특강</a:t>
             </a:r>
           </a:p>
         </p:txBody>
@@ -23810,7 +23810,7 @@
                 <a:ea typeface="NanumGothic"/>
                 <a:cs typeface="NanumGothic"/>
               </a:rPr>
-              <a:t>AI 에이전트와 응용  ·  원광대학교 5일 교육</a:t>
+              <a:t>신약 개발을 위한 AI Agent 특강</a:t>
             </a:r>
           </a:p>
         </p:txBody>
@@ -24933,7 +24933,7 @@
                 <a:ea typeface="NanumGothic"/>
                 <a:cs typeface="NanumGothic"/>
               </a:rPr>
-              <a:t>AI 에이전트와 응용  ·  원광대학교 5일 교육</a:t>
+              <a:t>신약 개발을 위한 AI Agent 특강</a:t>
             </a:r>
           </a:p>
         </p:txBody>
@@ -25938,7 +25938,7 @@
                 <a:ea typeface="NanumGothic"/>
                 <a:cs typeface="NanumGothic"/>
               </a:rPr>
-              <a:t>AI 에이전트와 응용  ·  원광대학교 5일 교육</a:t>
+              <a:t>신약 개발을 위한 AI Agent 특강</a:t>
             </a:r>
           </a:p>
         </p:txBody>
@@ -26943,7 +26943,7 @@
                 <a:ea typeface="NanumGothic"/>
                 <a:cs typeface="NanumGothic"/>
               </a:rPr>
-              <a:t>AI 에이전트와 응용  ·  원광대학교 5일 교육</a:t>
+              <a:t>신약 개발을 위한 AI Agent 특강</a:t>
             </a:r>
           </a:p>
         </p:txBody>
@@ -27948,7 +27948,7 @@
                 <a:ea typeface="NanumGothic"/>
                 <a:cs typeface="NanumGothic"/>
               </a:rPr>
-              <a:t>AI 에이전트와 응용  ·  원광대학교 5일 교육</a:t>
+              <a:t>신약 개발을 위한 AI Agent 특강</a:t>
             </a:r>
           </a:p>
         </p:txBody>
@@ -28711,7 +28711,7 @@
                 <a:ea typeface="NanumGothic"/>
                 <a:cs typeface="NanumGothic"/>
               </a:rPr>
-              <a:t>AI 에이전트와 응용  ·  원광대학교 5일 교육</a:t>
+              <a:t>신약 개발을 위한 AI Agent 특강</a:t>
             </a:r>
           </a:p>
         </p:txBody>
@@ -29474,7 +29474,7 @@
                 <a:ea typeface="NanumGothic"/>
                 <a:cs typeface="NanumGothic"/>
               </a:rPr>
-              <a:t>AI 에이전트와 응용  ·  원광대학교 5일 교육</a:t>
+              <a:t>신약 개발을 위한 AI Agent 특강</a:t>
             </a:r>
           </a:p>
         </p:txBody>
@@ -30237,7 +30237,7 @@
                 <a:ea typeface="NanumGothic"/>
                 <a:cs typeface="NanumGothic"/>
               </a:rPr>
-              <a:t>AI 에이전트와 응용  ·  원광대학교 5일 교육</a:t>
+              <a:t>신약 개발을 위한 AI Agent 특강</a:t>
             </a:r>
           </a:p>
         </p:txBody>
@@ -31000,7 +31000,7 @@
                 <a:ea typeface="NanumGothic"/>
                 <a:cs typeface="NanumGothic"/>
               </a:rPr>
-              <a:t>AI 에이전트와 응용  ·  원광대학교 5일 교육</a:t>
+              <a:t>신약 개발을 위한 AI Agent 특강</a:t>
             </a:r>
           </a:p>
         </p:txBody>
@@ -31867,7 +31867,7 @@
                 <a:ea typeface="NanumGothic"/>
                 <a:cs typeface="NanumGothic"/>
               </a:rPr>
-              <a:t>AI 에이전트와 응용  ·  원광대학교 5일 교육</a:t>
+              <a:t>신약 개발을 위한 AI Agent 특강</a:t>
             </a:r>
           </a:p>
         </p:txBody>
@@ -32954,7 +32954,7 @@
                 <a:ea typeface="NanumGothic"/>
                 <a:cs typeface="NanumGothic"/>
               </a:rPr>
-              <a:t>AI 에이전트와 응용  ·  원광대학교 5일 교육</a:t>
+              <a:t>신약 개발을 위한 AI Agent 특강</a:t>
             </a:r>
           </a:p>
         </p:txBody>
@@ -33959,7 +33959,7 @@
                 <a:ea typeface="NanumGothic"/>
                 <a:cs typeface="NanumGothic"/>
               </a:rPr>
-              <a:t>AI 에이전트와 응용  ·  원광대학교 5일 교육</a:t>
+              <a:t>신약 개발을 위한 AI Agent 특강</a:t>
             </a:r>
           </a:p>
         </p:txBody>
@@ -36472,7 +36472,7 @@
                 <a:ea typeface="NanumGothic"/>
                 <a:cs typeface="NanumGothic"/>
               </a:rPr>
-              <a:t>AI 에이전트와 응용  ·  원광대학교 5일 교육</a:t>
+              <a:t>신약 개발을 위한 AI Agent 특강</a:t>
             </a:r>
           </a:p>
         </p:txBody>
@@ -37339,7 +37339,7 @@
                 <a:ea typeface="NanumGothic"/>
                 <a:cs typeface="NanumGothic"/>
               </a:rPr>
-              <a:t>AI 에이전트와 응용  ·  원광대학교 5일 교육</a:t>
+              <a:t>신약 개발을 위한 AI Agent 특강</a:t>
             </a:r>
           </a:p>
         </p:txBody>
@@ -38206,7 +38206,7 @@
                 <a:ea typeface="NanumGothic"/>
                 <a:cs typeface="NanumGothic"/>
               </a:rPr>
-              <a:t>AI 에이전트와 응용  ·  원광대학교 5일 교육</a:t>
+              <a:t>신약 개발을 위한 AI Agent 특강</a:t>
             </a:r>
           </a:p>
         </p:txBody>
@@ -39015,7 +39015,7 @@
                 <a:ea typeface="NanumGothic"/>
                 <a:cs typeface="NanumGothic"/>
               </a:rPr>
-              <a:t>AI 에이전트와 응용  ·  원광대학교 5일 교육</a:t>
+              <a:t>신약 개발을 위한 AI Agent 특강</a:t>
             </a:r>
           </a:p>
         </p:txBody>
@@ -39778,7 +39778,7 @@
                 <a:ea typeface="NanumGothic"/>
                 <a:cs typeface="NanumGothic"/>
               </a:rPr>
-              <a:t>AI 에이전트와 응용  ·  원광대학교 5일 교육</a:t>
+              <a:t>신약 개발을 위한 AI Agent 특강</a:t>
             </a:r>
           </a:p>
         </p:txBody>
@@ -41574,7 +41574,7 @@
                 <a:ea typeface="NanumGothic"/>
                 <a:cs typeface="NanumGothic"/>
               </a:rPr>
-              <a:t>AI 에이전트와 응용  ·  원광대학교 5일 교육</a:t>
+              <a:t>신약 개발을 위한 AI Agent 특강</a:t>
             </a:r>
           </a:p>
         </p:txBody>
@@ -42441,7 +42441,7 @@
                 <a:ea typeface="NanumGothic"/>
                 <a:cs typeface="NanumGothic"/>
               </a:rPr>
-              <a:t>AI 에이전트와 응용  ·  원광대학교 5일 교육</a:t>
+              <a:t>신약 개발을 위한 AI Agent 특강</a:t>
             </a:r>
           </a:p>
         </p:txBody>
@@ -43308,7 +43308,7 @@
                 <a:ea typeface="NanumGothic"/>
                 <a:cs typeface="NanumGothic"/>
               </a:rPr>
-              <a:t>AI 에이전트와 응용  ·  원광대학교 5일 교육</a:t>
+              <a:t>신약 개발을 위한 AI Agent 특강</a:t>
             </a:r>
           </a:p>
         </p:txBody>

</xml_diff>

<commit_message>
Rewrite all 57 slide NOTEs as professional complete sentences
Academic tone for pharmacy-student special lecture; NOTE stays 요약/주의/연결.
Audience (약학 대학생 · 신약개발 AI 특강) recorded in memory.

Co-Authored-By: Claude Opus 4.8 <noreply@anthropic.com>
</commit_message>
<xml_diff>
--- a/slides/day1.pptx
+++ b/slides/day1.pptx
@@ -4496,7 +4496,7 @@
                 <a:ea typeface="NanumGothic"/>
                 <a:cs typeface="NanumGothic"/>
               </a:rPr>
-              <a:t>능력(사전학습)과 말귀(정렬)가 합쳐진 순간</a:t>
+              <a:t>방대한 능력을 갖춘 사전학습과 지시를 따르게 하는 정렬이 결합되어 대중화가 이루어진 시점이다.</a:t>
             </a:r>
           </a:p>
         </p:txBody>
@@ -5363,7 +5363,7 @@
                 <a:ea typeface="NanumGothic"/>
                 <a:cs typeface="NanumGothic"/>
               </a:rPr>
-              <a:t>오늘 우리가 쓰는 모델들이 여기</a:t>
+              <a:t>오늘날 우리가 사용하는 모델들이 바로 이 단계에 해당한다.</a:t>
             </a:r>
           </a:p>
         </p:txBody>
@@ -6368,7 +6368,7 @@
                 <a:ea typeface="NanumGothic"/>
                 <a:cs typeface="NanumGothic"/>
               </a:rPr>
-              <a:t>의미를 아는 게 아니라 통계로 '다음 토큰'을 맞히는 것</a:t>
+              <a:t>LLM은 의미를 이해하는 것이 아니라 통계적으로 '다음 토큰'을 예측한다는 점을 기억해야 한다.</a:t>
             </a:r>
           </a:p>
         </p:txBody>
@@ -7886,7 +7886,7 @@
                 <a:ea typeface="NanumGothic"/>
                 <a:cs typeface="NanumGothic"/>
               </a:rPr>
-              <a:t>한 번에 한 토큰씩, 반복해서 생성 (autoregressive) — 이제 각 단계를 하나씩</a:t>
+              <a:t>한 번에 한 토큰씩 예측하여 반복적으로 생성하는 방식(autoregressive)이며, 이어서 각 단계를 차례로 살펴본다.</a:t>
             </a:r>
           </a:p>
         </p:txBody>
@@ -8891,7 +8891,7 @@
                 <a:ea typeface="NanumGothic"/>
                 <a:cs typeface="NanumGothic"/>
               </a:rPr>
-              <a:t>토큰 수가 곧 길이·비용 — 한글이 더 많이 든다</a:t>
+              <a:t>토큰 수가 곧 입력의 길이와 비용을 결정하며, 한글은 영어보다 더 많은 토큰을 사용한다.</a:t>
             </a:r>
           </a:p>
         </p:txBody>
@@ -9758,7 +9758,7 @@
                 <a:ea typeface="NanumGothic"/>
                 <a:cs typeface="NanumGothic"/>
               </a:rPr>
-              <a:t>모델이 아는 건 사실이 아니라 '그럴듯함' — 환각의 뿌리</a:t>
+              <a:t>모델이 다루는 것은 사실이 아니라 '그럴듯함'이며, 이것이 환각이 발생하는 근본 원인이다.</a:t>
             </a:r>
           </a:p>
         </p:txBody>
@@ -10625,7 +10625,7 @@
                 <a:ea typeface="NanumGothic"/>
                 <a:cs typeface="NanumGothic"/>
               </a:rPr>
-              <a:t>같은 질문에 매번 다른 답이 나오는 이유</a:t>
+              <a:t>동일한 질문에도 매번 다른 답이 나오는 이유가 바로 이 확률적 선택에 있다.</a:t>
             </a:r>
           </a:p>
         </p:txBody>
@@ -11492,7 +11492,7 @@
                 <a:ea typeface="NanumGothic"/>
                 <a:cs typeface="NanumGothic"/>
               </a:rPr>
-              <a:t>그래서 긴 출력은 중간 점검·검증이 중요</a:t>
+              <a:t>따라서 출력이 길어질수록 중간 점검과 검증이 더욱 중요해진다.</a:t>
             </a:r>
           </a:p>
         </p:txBody>
@@ -12497,7 +12497,7 @@
                 <a:ea typeface="NanumGothic"/>
                 <a:cs typeface="NanumGothic"/>
               </a:rPr>
-              <a:t>학습 시점·편향이 그대로 한계로 남는다</a:t>
+              <a:t>학습이 이루어진 시점과 데이터의 편향이 모델의 한계로 그대로 남는다.</a:t>
             </a:r>
           </a:p>
         </p:txBody>
@@ -13502,7 +13502,7 @@
                 <a:ea typeface="NanumGothic"/>
                 <a:cs typeface="NanumGothic"/>
               </a:rPr>
-              <a:t>능력은 같아도 정렬이 '지시 이행'을 만든다</a:t>
+              <a:t>기본 능력이 같더라도 정렬 과정이 '지시를 따르는 능력'을 만들어 낸다.</a:t>
             </a:r>
           </a:p>
         </p:txBody>
@@ -16014,7 +16014,7 @@
                 <a:ea typeface="NanumGothic"/>
                 <a:cs typeface="NanumGothic"/>
               </a:rPr>
-              <a:t>이제 각 단계를 하나씩</a:t>
+              <a:t>이어지는 슬라이드에서 정렬의 세 단계를 차례로 살펴본다.</a:t>
             </a:r>
           </a:p>
         </p:txBody>
@@ -19308,7 +19308,7 @@
                 <a:ea typeface="NanumGothic"/>
                 <a:cs typeface="NanumGothic"/>
               </a:rPr>
-              <a:t>벤치마크 수치는 빠르게 바뀜 — 강의 주에 재확인</a:t>
+              <a:t>벤치마크 수치는 빠르게 갱신되므로 강의 시점을 기준으로 다시 확인하는 것이 좋다.</a:t>
             </a:r>
           </a:p>
         </p:txBody>
@@ -20313,7 +20313,7 @@
                 <a:ea typeface="NanumGothic"/>
                 <a:cs typeface="NanumGothic"/>
               </a:rPr>
-              <a:t>키워드가 아니라 '의미'로 찾는다</a:t>
+              <a:t>임베딩은 키워드의 일치가 아니라 '의미'의 유사성으로 자료를 찾는다.</a:t>
             </a:r>
           </a:p>
         </p:txBody>
@@ -21831,7 +21831,7 @@
                 <a:ea typeface="NanumGothic"/>
                 <a:cs typeface="NanumGothic"/>
               </a:rPr>
-              <a:t>외부 지식을 붙여 환각↓·최신성↑ — 이제 각 단계를 하나씩</a:t>
+              <a:t>외부 지식을 결합해 환각을 줄이고 최신성을 높이는 방식이며, 이어서 각 단계를 차례로 살펴본다.</a:t>
             </a:r>
           </a:p>
         </p:txBody>
@@ -23461,7 +23461,7 @@
                 <a:ea typeface="NanumGothic"/>
                 <a:cs typeface="NanumGothic"/>
               </a:rPr>
-              <a:t>Day 1 임베딩이 여기서 쓰인다</a:t>
+              <a:t>오늘 학습한 임베딩이 바로 이 검색 단계에서 활용된다.</a:t>
             </a:r>
           </a:p>
         </p:txBody>
@@ -25589,7 +25589,7 @@
                 <a:ea typeface="NanumGothic"/>
                 <a:cs typeface="NanumGothic"/>
               </a:rPr>
-              <a:t>리서치 에이전트의 핵심 패턴</a:t>
+              <a:t>근거에 기반해 답하는 이 방식이 리서치 에이전트의 핵심 패턴이다.</a:t>
             </a:r>
           </a:p>
         </p:txBody>
@@ -26594,7 +26594,7 @@
                 <a:ea typeface="NanumGothic"/>
                 <a:cs typeface="NanumGothic"/>
               </a:rPr>
-              <a:t>같은 모델도 프롬프트가 출력을 좌우한다</a:t>
+              <a:t>같은 모델이라도 프롬프트의 구성이 출력의 품질을 좌우한다.</a:t>
             </a:r>
           </a:p>
         </p:txBody>
@@ -27599,7 +27599,7 @@
                 <a:ea typeface="NanumGothic"/>
                 <a:cs typeface="NanumGothic"/>
               </a:rPr>
-              <a:t>이제 각 기법을 하나씩</a:t>
+              <a:t>이어지는 슬라이드에서 세 가지 기법을 하나씩 살펴본다.</a:t>
             </a:r>
           </a:p>
         </p:txBody>
@@ -31518,7 +31518,7 @@
                 <a:ea typeface="NanumGothic"/>
                 <a:cs typeface="NanumGothic"/>
               </a:rPr>
-              <a:t>현재 Claude 최대 1M 토큰(≈책 여러 권) — 긴 문서·코드 통째 분석 (단 lost in the middle 주의)</a:t>
+              <a:t>현재 Claude는 최대 100만 토큰(책 여러 권 분량)을 처리하여 긴 문서나 코드를 통째로 분석할 수 있으나, 입력이 길수록 중간 내용을 놓칠 수 있음에 유의해야 한다.</a:t>
             </a:r>
           </a:p>
         </p:txBody>
@@ -33610,7 +33610,7 @@
                 <a:ea typeface="NanumGothic"/>
                 <a:cs typeface="NanumGothic"/>
               </a:rPr>
-              <a:t>그럴듯함 ≠ 사실 — 중요한 내용은 반드시 교차확인</a:t>
+              <a:t>그럴듯함은 사실과 다르므로, 중요한 내용은 반드시 출처로 교차확인해야 한다.</a:t>
             </a:r>
           </a:p>
         </p:txBody>
@@ -36990,7 +36990,7 @@
                 <a:ea typeface="NanumGothic"/>
                 <a:cs typeface="NanumGothic"/>
               </a:rPr>
-              <a:t>참고 가격(~2026.6, 1M토큰 입력/출력): Opus $5/$25 · Sonnet $3/$15 · Haiku $1/$5 (변동)</a:t>
+              <a:t>참고로 2026년 6월 기준 100만 토큰당 가격은 Opus가 입력 5달러·출력 25달러, Sonnet이 3·15달러, Haiku가 1·5달러이며, 가격은 변동될 수 있다.</a:t>
             </a:r>
           </a:p>
         </p:txBody>
@@ -37857,7 +37857,7 @@
                 <a:ea typeface="NanumGothic"/>
                 <a:cs typeface="NanumGothic"/>
               </a:rPr>
-              <a:t>오늘의 임베딩·RAG가 리서치 에이전트의 토대다</a:t>
+              <a:t>오늘 학습한 임베딩과 RAG가 리서치 에이전트의 토대가 된다.</a:t>
             </a:r>
           </a:p>
         </p:txBody>
@@ -41225,7 +41225,7 @@
                 <a:ea typeface="NanumGothic"/>
                 <a:cs typeface="NanumGothic"/>
               </a:rPr>
-              <a:t>초기 통계(n-gram) → 신경망 → Transformer로 도약 — 이제 각 단계를 하나씩</a:t>
+              <a:t>초기의 통계 기반 모델에서 신경망을 거쳐 Transformer로 도약한 흐름이며, 이어지는 슬라이드에서 각 단계를 차례로 살펴본다.</a:t>
             </a:r>
           </a:p>
         </p:txBody>
@@ -42092,7 +42092,7 @@
                 <a:ea typeface="NanumGothic"/>
                 <a:cs typeface="NanumGothic"/>
               </a:rPr>
-              <a:t>오늘 배울 '임베딩'의 출발점</a:t>
+              <a:t>오늘 학습할 '임베딩' 개념이 바로 이 시기에서 출발한다.</a:t>
             </a:r>
           </a:p>
         </p:txBody>
@@ -42959,7 +42959,7 @@
                 <a:ea typeface="NanumGothic"/>
                 <a:cs typeface="NanumGothic"/>
               </a:rPr>
-              <a:t>지금의 GPT·Claude 모두 이 구조 위에</a:t>
+              <a:t>현재의 GPT와 Claude를 비롯한 주요 모델은 모두 이 Transformer 구조 위에 만들어져 있다.</a:t>
             </a:r>
           </a:p>
         </p:txBody>
@@ -43826,7 +43826,7 @@
                 <a:ea typeface="NanumGothic"/>
                 <a:cs typeface="NanumGothic"/>
               </a:rPr>
-              <a:t>'사전학습'이라는 오늘의 핵심 개념이 자리잡음</a:t>
+              <a:t>오늘의 핵심 개념인 '사전학습'이 이 시기에 자리 잡았다.</a:t>
             </a:r>
           </a:p>
         </p:txBody>

</xml_diff>

<commit_message>
Day 1: replace awkward '점수기' with '보상 모델 / 답을 평가하는 모델'
Co-Authored-By: Claude Opus 4.8 <noreply@anthropic.com>
</commit_message>
<xml_diff>
--- a/slides/day1.pptx
+++ b/slides/day1.pptx
@@ -15632,7 +15632,7 @@
                 <a:ea typeface="NanumGothic"/>
                 <a:cs typeface="NanumGothic"/>
               </a:rPr>
-              <a:t>사람 선호로 '점수기' 학습</a:t>
+              <a:t>사람 선호로 '답 평가 모델' 학습</a:t>
             </a:r>
           </a:p>
         </p:txBody>
@@ -15910,7 +15910,7 @@
                 <a:ea typeface="NanumGothic"/>
                 <a:cs typeface="NanumGothic"/>
               </a:rPr>
-              <a:t>점수기로 좋은 답 쪽으로</a:t>
+              <a:t>보상 모델 점수가 높은 답 쪽으로</a:t>
             </a:r>
           </a:p>
         </p:txBody>
@@ -17035,7 +17035,7 @@
                 <a:ea typeface="NanumSquare"/>
                 <a:cs typeface="NanumSquare"/>
               </a:rPr>
-              <a:t>보상 모델 — '좋은 답' 점수기</a:t>
+              <a:t>보상 모델 — 답을 평가하는 모델</a:t>
             </a:r>
           </a:p>
         </p:txBody>
@@ -17264,7 +17264,7 @@
                 <a:ea typeface="NanumGothic"/>
                 <a:cs typeface="NanumGothic"/>
               </a:rPr>
-              <a:t>한 질문에 여러 답을 만들고, 사람이 좋은 순서로 순위</a:t>
+              <a:t>한 질문에 여러 답을 만들고, 사람이 좋은 순서로 순위를 매김</a:t>
             </a:r>
           </a:p>
         </p:txBody>
@@ -17402,7 +17402,7 @@
                 <a:ea typeface="NanumGothic"/>
                 <a:cs typeface="NanumGothic"/>
               </a:rPr>
-              <a:t>그 선호를 흉내내는 '점수 매기는 모델'을 따로 학습</a:t>
+              <a:t>그 선호를 학습해 답에 점수를 주는 '보상 모델'을 따로 만든다</a:t>
             </a:r>
           </a:p>
         </p:txBody>
@@ -17540,7 +17540,7 @@
                 <a:ea typeface="NanumGothic"/>
                 <a:cs typeface="NanumGothic"/>
               </a:rPr>
-              <a:t>사람이 매번 평가할 수 없으니 자동 채점기를 만든다</a:t>
+              <a:t>사람이 매번 평가할 수 없으니, 답을 자동으로 평가하는 모델이 필요</a:t>
             </a:r>
           </a:p>
         </p:txBody>

</xml_diff>

<commit_message>
Add OpenAI tokenizer link to 토큰화 slide; adaptive bullet spacing
- 토큰화 slide: + '직접 해보기' platform.openai.com/tokenizer (body bullet)
- slide_bullets: compress spacing by item count so 5 bullets clear the NOTE band

Co-Authored-By: Claude Opus 4.8 <noreply@anthropic.com>
</commit_message>
<xml_diff>
--- a/slides/day1.pptx
+++ b/slides/day1.pptx
@@ -8387,7 +8387,7 @@
         </p:nvSpPr>
         <p:spPr>
           <a:xfrm>
-            <a:off x="548640" y="2779776"/>
+            <a:off x="548640" y="2633472"/>
             <a:ext cx="146304" cy="146304"/>
           </a:xfrm>
           <a:prstGeom prst="ellipse">
@@ -8431,7 +8431,7 @@
         </p:nvSpPr>
         <p:spPr>
           <a:xfrm>
-            <a:off x="868680" y="2697480"/>
+            <a:off x="868680" y="2551176"/>
             <a:ext cx="10607040" cy="457200"/>
           </a:xfrm>
           <a:prstGeom prst="rect">
@@ -8478,7 +8478,7 @@
         </p:nvSpPr>
         <p:spPr>
           <a:xfrm>
-            <a:off x="868680" y="3081528"/>
+            <a:off x="868680" y="2935224"/>
             <a:ext cx="10607040" cy="457200"/>
           </a:xfrm>
           <a:prstGeom prst="rect">
@@ -8525,7 +8525,7 @@
         </p:nvSpPr>
         <p:spPr>
           <a:xfrm>
-            <a:off x="548640" y="3648456"/>
+            <a:off x="548640" y="3355848"/>
             <a:ext cx="146304" cy="146304"/>
           </a:xfrm>
           <a:prstGeom prst="ellipse">
@@ -8569,7 +8569,7 @@
         </p:nvSpPr>
         <p:spPr>
           <a:xfrm>
-            <a:off x="868680" y="3566160"/>
+            <a:off x="868680" y="3273552"/>
             <a:ext cx="10607040" cy="457200"/>
           </a:xfrm>
           <a:prstGeom prst="rect">
@@ -8616,7 +8616,7 @@
         </p:nvSpPr>
         <p:spPr>
           <a:xfrm>
-            <a:off x="868680" y="3950208"/>
+            <a:off x="868680" y="3657600"/>
             <a:ext cx="10607040" cy="457200"/>
           </a:xfrm>
           <a:prstGeom prst="rect">
@@ -8663,7 +8663,7 @@
         </p:nvSpPr>
         <p:spPr>
           <a:xfrm>
-            <a:off x="548640" y="4517136"/>
+            <a:off x="548640" y="4078224"/>
             <a:ext cx="146304" cy="146304"/>
           </a:xfrm>
           <a:prstGeom prst="ellipse">
@@ -8707,7 +8707,7 @@
         </p:nvSpPr>
         <p:spPr>
           <a:xfrm>
-            <a:off x="868680" y="4434840"/>
+            <a:off x="868680" y="3995928"/>
             <a:ext cx="10607040" cy="457200"/>
           </a:xfrm>
           <a:prstGeom prst="rect">
@@ -8754,7 +8754,7 @@
         </p:nvSpPr>
         <p:spPr>
           <a:xfrm>
-            <a:off x="868680" y="4818888"/>
+            <a:off x="868680" y="4379976"/>
             <a:ext cx="10607040" cy="457200"/>
           </a:xfrm>
           <a:prstGeom prst="rect">
@@ -8795,7 +8795,145 @@
       </p:sp>
       <p:sp>
         <p:nvSpPr>
-          <p:cNvPr id="20" name="Rounded Rectangle 19"/>
+          <p:cNvPr id="20" name="Oval 19"/>
+          <p:cNvSpPr/>
+          <p:nvPr/>
+        </p:nvSpPr>
+        <p:spPr>
+          <a:xfrm>
+            <a:off x="548640" y="4800600"/>
+            <a:ext cx="146304" cy="146304"/>
+          </a:xfrm>
+          <a:prstGeom prst="ellipse">
+            <a:avLst/>
+          </a:prstGeom>
+          <a:solidFill>
+            <a:srgbClr val="6366F1"/>
+          </a:solidFill>
+          <a:ln>
+            <a:noFill/>
+          </a:ln>
+          <a:effectLst/>
+        </p:spPr>
+        <p:style>
+          <a:lnRef idx="1">
+            <a:schemeClr val="accent1"/>
+          </a:lnRef>
+          <a:fillRef idx="3">
+            <a:schemeClr val="accent1"/>
+          </a:fillRef>
+          <a:effectRef idx="2">
+            <a:schemeClr val="accent1"/>
+          </a:effectRef>
+          <a:fontRef idx="minor">
+            <a:schemeClr val="lt1"/>
+          </a:fontRef>
+        </p:style>
+        <p:txBody>
+          <a:bodyPr rtlCol="0" anchor="ctr"/>
+          <a:lstStyle/>
+          <a:p>
+            <a:pPr algn="ctr"/>
+          </a:p>
+        </p:txBody>
+      </p:sp>
+      <p:sp>
+        <p:nvSpPr>
+          <p:cNvPr id="21" name="TextBox 20"/>
+          <p:cNvSpPr txBox="1"/>
+          <p:nvPr/>
+        </p:nvSpPr>
+        <p:spPr>
+          <a:xfrm>
+            <a:off x="868680" y="4718304"/>
+            <a:ext cx="10607040" cy="457200"/>
+          </a:xfrm>
+          <a:prstGeom prst="rect">
+            <a:avLst/>
+          </a:prstGeom>
+          <a:noFill/>
+        </p:spPr>
+        <p:txBody>
+          <a:bodyPr wrap="square" anchor="t" lIns="0" rIns="0" tIns="0" bIns="0">
+            <a:spAutoFit/>
+          </a:bodyPr>
+          <a:lstStyle/>
+          <a:p>
+            <a:pPr algn="l">
+              <a:lnSpc>
+                <a:spcPct val="100000"/>
+              </a:lnSpc>
+              <a:spcBef>
+                <a:spcPts val="0"/>
+              </a:spcBef>
+              <a:spcAft>
+                <a:spcPts val="600"/>
+              </a:spcAft>
+            </a:pPr>
+            <a:r>
+              <a:rPr sz="1600" b="1">
+                <a:solidFill>
+                  <a:srgbClr val="0F172A"/>
+                </a:solidFill>
+                <a:latin typeface="NanumGothic"/>
+                <a:ea typeface="NanumGothic"/>
+                <a:cs typeface="NanumGothic"/>
+              </a:rPr>
+              <a:t>직접 해보기</a:t>
+            </a:r>
+          </a:p>
+        </p:txBody>
+      </p:sp>
+      <p:sp>
+        <p:nvSpPr>
+          <p:cNvPr id="22" name="TextBox 21"/>
+          <p:cNvSpPr txBox="1"/>
+          <p:nvPr/>
+        </p:nvSpPr>
+        <p:spPr>
+          <a:xfrm>
+            <a:off x="868680" y="5102352"/>
+            <a:ext cx="10607040" cy="457200"/>
+          </a:xfrm>
+          <a:prstGeom prst="rect">
+            <a:avLst/>
+          </a:prstGeom>
+          <a:noFill/>
+        </p:spPr>
+        <p:txBody>
+          <a:bodyPr wrap="square" anchor="t" lIns="0" rIns="0" tIns="0" bIns="0">
+            <a:spAutoFit/>
+          </a:bodyPr>
+          <a:lstStyle/>
+          <a:p>
+            <a:pPr algn="l">
+              <a:lnSpc>
+                <a:spcPct val="100000"/>
+              </a:lnSpc>
+              <a:spcBef>
+                <a:spcPts val="0"/>
+              </a:spcBef>
+              <a:spcAft>
+                <a:spcPts val="600"/>
+              </a:spcAft>
+            </a:pPr>
+            <a:r>
+              <a:rPr sz="1300" b="0">
+                <a:solidFill>
+                  <a:srgbClr val="64748B"/>
+                </a:solidFill>
+                <a:latin typeface="NanumGothic"/>
+                <a:ea typeface="NanumGothic"/>
+                <a:cs typeface="NanumGothic"/>
+              </a:rPr>
+              <a:t>platform.openai.com/tokenizer — 문장을 넣어 토큰이 어떻게 쪼개지는지 확인</a:t>
+            </a:r>
+          </a:p>
+        </p:txBody>
+      </p:sp>
+      <p:sp>
+        <p:nvSpPr>
+          <p:cNvPr id="23" name="Rounded Rectangle 22"/>
           <p:cNvSpPr/>
           <p:nvPr/>
         </p:nvSpPr>
@@ -8841,7 +8979,7 @@
       </p:sp>
       <p:sp>
         <p:nvSpPr>
-          <p:cNvPr id="21" name="TextBox 20"/>
+          <p:cNvPr id="24" name="TextBox 23"/>
           <p:cNvSpPr txBox="1"/>
           <p:nvPr/>
         </p:nvSpPr>
@@ -8899,7 +9037,7 @@
       </p:sp>
       <p:sp>
         <p:nvSpPr>
-          <p:cNvPr id="22" name="TextBox 21"/>
+          <p:cNvPr id="25" name="TextBox 24"/>
           <p:cNvSpPr txBox="1"/>
           <p:nvPr/>
         </p:nvSpPr>

</xml_diff>